<commit_message>
Product- Working with image gallery (part - 1)
</commit_message>
<xml_diff>
--- a/.lessons/58 Backend Product And Related Features/16 Product- Working with image gallery (part - 1)/1.pptx
+++ b/.lessons/58 Backend Product And Related Features/16 Product- Working with image gallery (part - 1)/1.pptx
@@ -6,8 +6,14 @@
   </p:sldMasterIdLst>
   <p:sldIdLst>
     <p:sldId id="413" r:id="rId2"/>
-    <p:sldId id="414" r:id="rId3"/>
-    <p:sldId id="400" r:id="rId4"/>
+    <p:sldId id="415" r:id="rId3"/>
+    <p:sldId id="416" r:id="rId4"/>
+    <p:sldId id="414" r:id="rId5"/>
+    <p:sldId id="417" r:id="rId6"/>
+    <p:sldId id="418" r:id="rId7"/>
+    <p:sldId id="419" r:id="rId8"/>
+    <p:sldId id="420" r:id="rId9"/>
+    <p:sldId id="400" r:id="rId10"/>
   </p:sldIdLst>
   <p:sldSz cx="12192000" cy="6858000"/>
   <p:notesSz cx="6858000" cy="9144000"/>
@@ -261,7 +267,7 @@
           <a:p>
             <a:fld id="{3E102D2E-813C-461C-9963-687A650C48C0}" type="datetimeFigureOut">
               <a:rPr lang="en-US" smtClean="0"/>
-              <a:t>6/26/2025</a:t>
+              <a:t>10/7/2025</a:t>
             </a:fld>
             <a:endParaRPr lang="en-US"/>
           </a:p>
@@ -459,7 +465,7 @@
           <a:p>
             <a:fld id="{3E102D2E-813C-461C-9963-687A650C48C0}" type="datetimeFigureOut">
               <a:rPr lang="en-US" smtClean="0"/>
-              <a:t>6/26/2025</a:t>
+              <a:t>10/7/2025</a:t>
             </a:fld>
             <a:endParaRPr lang="en-US"/>
           </a:p>
@@ -667,7 +673,7 @@
           <a:p>
             <a:fld id="{3E102D2E-813C-461C-9963-687A650C48C0}" type="datetimeFigureOut">
               <a:rPr lang="en-US" smtClean="0"/>
-              <a:t>6/26/2025</a:t>
+              <a:t>10/7/2025</a:t>
             </a:fld>
             <a:endParaRPr lang="en-US"/>
           </a:p>
@@ -865,7 +871,7 @@
           <a:p>
             <a:fld id="{3E102D2E-813C-461C-9963-687A650C48C0}" type="datetimeFigureOut">
               <a:rPr lang="en-US" smtClean="0"/>
-              <a:t>6/26/2025</a:t>
+              <a:t>10/7/2025</a:t>
             </a:fld>
             <a:endParaRPr lang="en-US"/>
           </a:p>
@@ -1140,7 +1146,7 @@
           <a:p>
             <a:fld id="{3E102D2E-813C-461C-9963-687A650C48C0}" type="datetimeFigureOut">
               <a:rPr lang="en-US" smtClean="0"/>
-              <a:t>6/26/2025</a:t>
+              <a:t>10/7/2025</a:t>
             </a:fld>
             <a:endParaRPr lang="en-US"/>
           </a:p>
@@ -1405,7 +1411,7 @@
           <a:p>
             <a:fld id="{3E102D2E-813C-461C-9963-687A650C48C0}" type="datetimeFigureOut">
               <a:rPr lang="en-US" smtClean="0"/>
-              <a:t>6/26/2025</a:t>
+              <a:t>10/7/2025</a:t>
             </a:fld>
             <a:endParaRPr lang="en-US"/>
           </a:p>
@@ -1817,7 +1823,7 @@
           <a:p>
             <a:fld id="{3E102D2E-813C-461C-9963-687A650C48C0}" type="datetimeFigureOut">
               <a:rPr lang="en-US" smtClean="0"/>
-              <a:t>6/26/2025</a:t>
+              <a:t>10/7/2025</a:t>
             </a:fld>
             <a:endParaRPr lang="en-US"/>
           </a:p>
@@ -1958,7 +1964,7 @@
           <a:p>
             <a:fld id="{3E102D2E-813C-461C-9963-687A650C48C0}" type="datetimeFigureOut">
               <a:rPr lang="en-US" smtClean="0"/>
-              <a:t>6/26/2025</a:t>
+              <a:t>10/7/2025</a:t>
             </a:fld>
             <a:endParaRPr lang="en-US"/>
           </a:p>
@@ -2071,7 +2077,7 @@
           <a:p>
             <a:fld id="{3E102D2E-813C-461C-9963-687A650C48C0}" type="datetimeFigureOut">
               <a:rPr lang="en-US" smtClean="0"/>
-              <a:t>6/26/2025</a:t>
+              <a:t>10/7/2025</a:t>
             </a:fld>
             <a:endParaRPr lang="en-US"/>
           </a:p>
@@ -2382,7 +2388,7 @@
           <a:p>
             <a:fld id="{3E102D2E-813C-461C-9963-687A650C48C0}" type="datetimeFigureOut">
               <a:rPr lang="en-US" smtClean="0"/>
-              <a:t>6/26/2025</a:t>
+              <a:t>10/7/2025</a:t>
             </a:fld>
             <a:endParaRPr lang="en-US"/>
           </a:p>
@@ -2670,7 +2676,7 @@
           <a:p>
             <a:fld id="{3E102D2E-813C-461C-9963-687A650C48C0}" type="datetimeFigureOut">
               <a:rPr lang="en-US" smtClean="0"/>
-              <a:t>6/26/2025</a:t>
+              <a:t>10/7/2025</a:t>
             </a:fld>
             <a:endParaRPr lang="en-US"/>
           </a:p>
@@ -2911,7 +2917,7 @@
           <a:p>
             <a:fld id="{3E102D2E-813C-461C-9963-687A650C48C0}" type="datetimeFigureOut">
               <a:rPr lang="en-US" smtClean="0"/>
-              <a:t>6/26/2025</a:t>
+              <a:t>10/7/2025</a:t>
             </a:fld>
             <a:endParaRPr lang="en-US"/>
           </a:p>
@@ -3349,7 +3355,7 @@
         <p:spPr>
           <a:xfrm>
             <a:off x="217714" y="255046"/>
-            <a:ext cx="11756571" cy="355354"/>
+            <a:ext cx="11756571" cy="5156668"/>
           </a:xfrm>
           <a:prstGeom prst="rect">
             <a:avLst/>
@@ -3368,6 +3374,65 @@
               </a:lnSpc>
               <a:buNone/>
             </a:pPr>
+            <a:r>
+              <a:rPr lang="az-Latn-AZ" altLang="en-US" sz="1300" b="1">
+                <a:latin typeface="Arial" panose="020B0604020202020204" pitchFamily="34" charset="0"/>
+              </a:rPr>
+              <a:t>Product</a:t>
+            </a:r>
+            <a:r>
+              <a:rPr lang="az-Latn-AZ" altLang="en-US" sz="1300">
+                <a:latin typeface="Arial" panose="020B0604020202020204" pitchFamily="34" charset="0"/>
+              </a:rPr>
+              <a:t> üçün çoxlu şəkil əlavə edə biləcəyimiz </a:t>
+            </a:r>
+            <a:r>
+              <a:rPr lang="az-Latn-AZ" altLang="en-US" sz="1300" b="1">
+                <a:latin typeface="Arial" panose="020B0604020202020204" pitchFamily="34" charset="0"/>
+              </a:rPr>
+              <a:t>İmage Galery </a:t>
+            </a:r>
+            <a:r>
+              <a:rPr lang="az-Latn-AZ" altLang="en-US" sz="1300">
+                <a:latin typeface="Arial" panose="020B0604020202020204" pitchFamily="34" charset="0"/>
+              </a:rPr>
+              <a:t>adlı prinsipdən istifadə edəcəyik bu dərs.</a:t>
+            </a:r>
+            <a:endParaRPr lang="en-US" altLang="en-US" sz="1300">
+              <a:latin typeface="Arial" panose="020B0604020202020204" pitchFamily="34" charset="0"/>
+            </a:endParaRPr>
+          </a:p>
+          <a:p>
+            <a:pPr>
+              <a:lnSpc>
+                <a:spcPct val="150000"/>
+              </a:lnSpc>
+              <a:buNone/>
+            </a:pPr>
+            <a:endParaRPr kumimoji="0" lang="en-US" altLang="en-US" sz="1300" b="0" i="0" u="none" strike="noStrike" cap="none" normalizeH="0" baseline="0">
+              <a:ln>
+                <a:noFill/>
+              </a:ln>
+              <a:solidFill>
+                <a:schemeClr val="tx1"/>
+              </a:solidFill>
+              <a:effectLst/>
+              <a:latin typeface="Arial" panose="020B0604020202020204" pitchFamily="34" charset="0"/>
+            </a:endParaRPr>
+          </a:p>
+          <a:p>
+            <a:pPr>
+              <a:lnSpc>
+                <a:spcPct val="150000"/>
+              </a:lnSpc>
+              <a:buNone/>
+            </a:pPr>
+            <a:r>
+              <a:rPr lang="az-Latn-AZ" altLang="en-US" sz="1300">
+                <a:latin typeface="Arial" panose="020B0604020202020204" pitchFamily="34" charset="0"/>
+              </a:rPr>
+              <a:t>İ</a:t>
+            </a:r>
             <a:r>
               <a:rPr kumimoji="0" lang="en-US" altLang="en-US" sz="1300" b="0" i="0" u="none" strike="noStrike" cap="none" normalizeH="0" baseline="0">
                 <a:ln>
@@ -3379,11 +3444,361 @@
                 <a:effectLst/>
                 <a:latin typeface="Arial" panose="020B0604020202020204" pitchFamily="34" charset="0"/>
               </a:rPr>
-              <a:t>.</a:t>
-            </a:r>
-          </a:p>
-        </p:txBody>
-      </p:sp>
+              <a:t>lk olaraq </a:t>
+            </a:r>
+            <a:r>
+              <a:rPr kumimoji="0" lang="en-US" altLang="en-US" sz="1300" b="1" i="0" u="none" strike="noStrike" cap="none" normalizeH="0" baseline="0">
+                <a:ln>
+                  <a:noFill/>
+                </a:ln>
+                <a:solidFill>
+                  <a:schemeClr val="tx1"/>
+                </a:solidFill>
+                <a:effectLst/>
+                <a:latin typeface="Arial" panose="020B0604020202020204" pitchFamily="34" charset="0"/>
+              </a:rPr>
+              <a:t>Controller</a:t>
+            </a:r>
+            <a:r>
+              <a:rPr kumimoji="0" lang="en-US" altLang="en-US" sz="1300" b="0" i="0" u="none" strike="noStrike" cap="none" normalizeH="0" baseline="0">
+                <a:ln>
+                  <a:noFill/>
+                </a:ln>
+                <a:solidFill>
+                  <a:schemeClr val="tx1"/>
+                </a:solidFill>
+                <a:effectLst/>
+                <a:latin typeface="Arial" panose="020B0604020202020204" pitchFamily="34" charset="0"/>
+              </a:rPr>
+              <a:t> yarad</a:t>
+            </a:r>
+            <a:r>
+              <a:rPr lang="az-Latn-AZ" altLang="en-US" sz="1300">
+                <a:latin typeface="Arial" panose="020B0604020202020204" pitchFamily="34" charset="0"/>
+              </a:rPr>
+              <a:t>ırıq.</a:t>
+            </a:r>
+            <a:endParaRPr lang="en-US" altLang="en-US" sz="1300">
+              <a:latin typeface="Arial" panose="020B0604020202020204" pitchFamily="34" charset="0"/>
+            </a:endParaRPr>
+          </a:p>
+          <a:p>
+            <a:pPr>
+              <a:lnSpc>
+                <a:spcPct val="150000"/>
+              </a:lnSpc>
+              <a:buNone/>
+            </a:pPr>
+            <a:endParaRPr kumimoji="0" lang="en-US" altLang="en-US" sz="1300" b="0" i="0" u="none" strike="noStrike" cap="none" normalizeH="0" baseline="0">
+              <a:ln>
+                <a:noFill/>
+              </a:ln>
+              <a:solidFill>
+                <a:schemeClr val="tx1"/>
+              </a:solidFill>
+              <a:effectLst/>
+              <a:latin typeface="Arial" panose="020B0604020202020204" pitchFamily="34" charset="0"/>
+            </a:endParaRPr>
+          </a:p>
+          <a:p>
+            <a:pPr>
+              <a:lnSpc>
+                <a:spcPct val="150000"/>
+              </a:lnSpc>
+              <a:buNone/>
+            </a:pPr>
+            <a:endParaRPr lang="en-US" altLang="en-US" sz="1300">
+              <a:latin typeface="Arial" panose="020B0604020202020204" pitchFamily="34" charset="0"/>
+            </a:endParaRPr>
+          </a:p>
+          <a:p>
+            <a:pPr>
+              <a:lnSpc>
+                <a:spcPct val="150000"/>
+              </a:lnSpc>
+              <a:buNone/>
+            </a:pPr>
+            <a:endParaRPr kumimoji="0" lang="en-US" altLang="en-US" sz="1300" b="0" i="0" u="none" strike="noStrike" cap="none" normalizeH="0" baseline="0">
+              <a:ln>
+                <a:noFill/>
+              </a:ln>
+              <a:solidFill>
+                <a:schemeClr val="tx1"/>
+              </a:solidFill>
+              <a:effectLst/>
+              <a:latin typeface="Arial" panose="020B0604020202020204" pitchFamily="34" charset="0"/>
+            </a:endParaRPr>
+          </a:p>
+          <a:p>
+            <a:pPr>
+              <a:lnSpc>
+                <a:spcPct val="150000"/>
+              </a:lnSpc>
+              <a:buNone/>
+            </a:pPr>
+            <a:endParaRPr lang="en-US" altLang="en-US" sz="1300">
+              <a:latin typeface="Arial" panose="020B0604020202020204" pitchFamily="34" charset="0"/>
+            </a:endParaRPr>
+          </a:p>
+          <a:p>
+            <a:pPr>
+              <a:lnSpc>
+                <a:spcPct val="150000"/>
+              </a:lnSpc>
+              <a:buNone/>
+            </a:pPr>
+            <a:endParaRPr kumimoji="0" lang="en-US" altLang="en-US" sz="1300" b="0" i="0" u="none" strike="noStrike" cap="none" normalizeH="0" baseline="0">
+              <a:ln>
+                <a:noFill/>
+              </a:ln>
+              <a:solidFill>
+                <a:schemeClr val="tx1"/>
+              </a:solidFill>
+              <a:effectLst/>
+              <a:latin typeface="Arial" panose="020B0604020202020204" pitchFamily="34" charset="0"/>
+            </a:endParaRPr>
+          </a:p>
+          <a:p>
+            <a:pPr>
+              <a:lnSpc>
+                <a:spcPct val="150000"/>
+              </a:lnSpc>
+              <a:buNone/>
+            </a:pPr>
+            <a:r>
+              <a:rPr lang="en-US" altLang="en-US" sz="1300">
+                <a:latin typeface="Arial" panose="020B0604020202020204" pitchFamily="34" charset="0"/>
+              </a:rPr>
+              <a:t>Sonra is</a:t>
+            </a:r>
+            <a:r>
+              <a:rPr lang="az-Latn-AZ" altLang="en-US" sz="1300">
+                <a:latin typeface="Arial" panose="020B0604020202020204" pitchFamily="34" charset="0"/>
+              </a:rPr>
+              <a:t>ə Model və Migration yaradırıq.</a:t>
+            </a:r>
+          </a:p>
+          <a:p>
+            <a:pPr>
+              <a:lnSpc>
+                <a:spcPct val="150000"/>
+              </a:lnSpc>
+              <a:buNone/>
+            </a:pPr>
+            <a:endParaRPr kumimoji="0" lang="az-Latn-AZ" altLang="en-US" sz="1300" b="0" i="0" u="none" strike="noStrike" cap="none" normalizeH="0" baseline="0">
+              <a:ln>
+                <a:noFill/>
+              </a:ln>
+              <a:solidFill>
+                <a:schemeClr val="tx1"/>
+              </a:solidFill>
+              <a:effectLst/>
+              <a:latin typeface="Arial" panose="020B0604020202020204" pitchFamily="34" charset="0"/>
+            </a:endParaRPr>
+          </a:p>
+          <a:p>
+            <a:pPr>
+              <a:lnSpc>
+                <a:spcPct val="150000"/>
+              </a:lnSpc>
+              <a:buNone/>
+            </a:pPr>
+            <a:endParaRPr lang="az-Latn-AZ" altLang="en-US" sz="1300">
+              <a:latin typeface="Arial" panose="020B0604020202020204" pitchFamily="34" charset="0"/>
+            </a:endParaRPr>
+          </a:p>
+          <a:p>
+            <a:pPr>
+              <a:lnSpc>
+                <a:spcPct val="150000"/>
+              </a:lnSpc>
+              <a:buNone/>
+            </a:pPr>
+            <a:endParaRPr kumimoji="0" lang="az-Latn-AZ" altLang="en-US" sz="1300" b="0" i="0" u="none" strike="noStrike" cap="none" normalizeH="0" baseline="0">
+              <a:ln>
+                <a:noFill/>
+              </a:ln>
+              <a:solidFill>
+                <a:schemeClr val="tx1"/>
+              </a:solidFill>
+              <a:effectLst/>
+              <a:latin typeface="Arial" panose="020B0604020202020204" pitchFamily="34" charset="0"/>
+            </a:endParaRPr>
+          </a:p>
+          <a:p>
+            <a:pPr>
+              <a:lnSpc>
+                <a:spcPct val="150000"/>
+              </a:lnSpc>
+              <a:buNone/>
+            </a:pPr>
+            <a:endParaRPr lang="az-Latn-AZ" altLang="en-US" sz="1300">
+              <a:latin typeface="Arial" panose="020B0604020202020204" pitchFamily="34" charset="0"/>
+            </a:endParaRPr>
+          </a:p>
+          <a:p>
+            <a:pPr>
+              <a:lnSpc>
+                <a:spcPct val="150000"/>
+              </a:lnSpc>
+              <a:buNone/>
+            </a:pPr>
+            <a:endParaRPr kumimoji="0" lang="az-Latn-AZ" altLang="en-US" sz="1300" b="0" i="0" u="none" strike="noStrike" cap="none" normalizeH="0" baseline="0">
+              <a:ln>
+                <a:noFill/>
+              </a:ln>
+              <a:solidFill>
+                <a:schemeClr val="tx1"/>
+              </a:solidFill>
+              <a:effectLst/>
+              <a:latin typeface="Arial" panose="020B0604020202020204" pitchFamily="34" charset="0"/>
+            </a:endParaRPr>
+          </a:p>
+          <a:p>
+            <a:pPr>
+              <a:lnSpc>
+                <a:spcPct val="150000"/>
+              </a:lnSpc>
+              <a:buNone/>
+            </a:pPr>
+            <a:endParaRPr lang="az-Latn-AZ" altLang="en-US" sz="1300">
+              <a:latin typeface="Arial" panose="020B0604020202020204" pitchFamily="34" charset="0"/>
+            </a:endParaRPr>
+          </a:p>
+          <a:p>
+            <a:pPr>
+              <a:lnSpc>
+                <a:spcPct val="150000"/>
+              </a:lnSpc>
+              <a:buNone/>
+            </a:pPr>
+            <a:endParaRPr kumimoji="0" lang="az-Latn-AZ" altLang="en-US" sz="1300" b="0" i="0" u="none" strike="noStrike" cap="none" normalizeH="0" baseline="0">
+              <a:ln>
+                <a:noFill/>
+              </a:ln>
+              <a:solidFill>
+                <a:schemeClr val="tx1"/>
+              </a:solidFill>
+              <a:effectLst/>
+              <a:latin typeface="Arial" panose="020B0604020202020204" pitchFamily="34" charset="0"/>
+            </a:endParaRPr>
+          </a:p>
+          <a:p>
+            <a:pPr>
+              <a:lnSpc>
+                <a:spcPct val="150000"/>
+              </a:lnSpc>
+              <a:buNone/>
+            </a:pPr>
+            <a:r>
+              <a:rPr lang="az-Latn-AZ" altLang="en-US" sz="1300">
+                <a:latin typeface="Arial" panose="020B0604020202020204" pitchFamily="34" charset="0"/>
+              </a:rPr>
+              <a:t>Sonra Datatable yaradırıq.</a:t>
+            </a:r>
+            <a:endParaRPr kumimoji="0" lang="en-US" altLang="en-US" sz="1300" b="0" i="0" u="none" strike="noStrike" cap="none" normalizeH="0" baseline="0">
+              <a:ln>
+                <a:noFill/>
+              </a:ln>
+              <a:solidFill>
+                <a:schemeClr val="tx1"/>
+              </a:solidFill>
+              <a:effectLst/>
+              <a:latin typeface="Arial" panose="020B0604020202020204" pitchFamily="34" charset="0"/>
+            </a:endParaRPr>
+          </a:p>
+        </p:txBody>
+      </p:sp>
+      <p:pic>
+        <p:nvPicPr>
+          <p:cNvPr id="4" name="Picture 3">
+            <a:extLst>
+              <a:ext uri="{FF2B5EF4-FFF2-40B4-BE49-F238E27FC236}">
+                <a16:creationId xmlns:a16="http://schemas.microsoft.com/office/drawing/2014/main" id="{59638164-C91A-F193-5412-6BC420D2B3AD}"/>
+              </a:ext>
+            </a:extLst>
+          </p:cNvPr>
+          <p:cNvPicPr>
+            <a:picLocks noChangeAspect="1"/>
+          </p:cNvPicPr>
+          <p:nvPr/>
+        </p:nvPicPr>
+        <p:blipFill>
+          <a:blip r:embed="rId2"/>
+          <a:stretch>
+            <a:fillRect/>
+          </a:stretch>
+        </p:blipFill>
+        <p:spPr>
+          <a:xfrm>
+            <a:off x="0" y="1266322"/>
+            <a:ext cx="9621593" cy="1000265"/>
+          </a:xfrm>
+          <a:prstGeom prst="rect">
+            <a:avLst/>
+          </a:prstGeom>
+        </p:spPr>
+      </p:pic>
+      <p:pic>
+        <p:nvPicPr>
+          <p:cNvPr id="6" name="Picture 5">
+            <a:extLst>
+              <a:ext uri="{FF2B5EF4-FFF2-40B4-BE49-F238E27FC236}">
+                <a16:creationId xmlns:a16="http://schemas.microsoft.com/office/drawing/2014/main" id="{3C7E0E0D-E639-63CA-CF8A-8B5B5A41C6BB}"/>
+              </a:ext>
+            </a:extLst>
+          </p:cNvPr>
+          <p:cNvPicPr>
+            <a:picLocks noChangeAspect="1"/>
+          </p:cNvPicPr>
+          <p:nvPr/>
+        </p:nvPicPr>
+        <p:blipFill>
+          <a:blip r:embed="rId3"/>
+          <a:stretch>
+            <a:fillRect/>
+          </a:stretch>
+        </p:blipFill>
+        <p:spPr>
+          <a:xfrm>
+            <a:off x="0" y="3011057"/>
+            <a:ext cx="10574226" cy="1629002"/>
+          </a:xfrm>
+          <a:prstGeom prst="rect">
+            <a:avLst/>
+          </a:prstGeom>
+        </p:spPr>
+      </p:pic>
+      <p:pic>
+        <p:nvPicPr>
+          <p:cNvPr id="8" name="Picture 7">
+            <a:extLst>
+              <a:ext uri="{FF2B5EF4-FFF2-40B4-BE49-F238E27FC236}">
+                <a16:creationId xmlns:a16="http://schemas.microsoft.com/office/drawing/2014/main" id="{F73A46D3-08ED-AB0D-1B61-5F9E3EA539B5}"/>
+              </a:ext>
+            </a:extLst>
+          </p:cNvPr>
+          <p:cNvPicPr>
+            <a:picLocks noChangeAspect="1"/>
+          </p:cNvPicPr>
+          <p:nvPr/>
+        </p:nvPicPr>
+        <p:blipFill>
+          <a:blip r:embed="rId4"/>
+          <a:stretch>
+            <a:fillRect/>
+          </a:stretch>
+        </p:blipFill>
+        <p:spPr>
+          <a:xfrm>
+            <a:off x="0" y="5542316"/>
+            <a:ext cx="8459381" cy="1324160"/>
+          </a:xfrm>
+          <a:prstGeom prst="rect">
+            <a:avLst/>
+          </a:prstGeom>
+        </p:spPr>
+      </p:pic>
     </p:spTree>
     <p:extLst>
       <p:ext uri="{BB962C8B-B14F-4D97-AF65-F5344CB8AC3E}">
@@ -3398,6 +3813,371 @@
 </file>
 
 <file path=ppt/slides/slide2.xml><?xml version="1.0" encoding="utf-8"?>
+<p:sld xmlns:a="http://schemas.openxmlformats.org/drawingml/2006/main" xmlns:r="http://schemas.openxmlformats.org/officeDocument/2006/relationships" xmlns:p="http://schemas.openxmlformats.org/presentationml/2006/main">
+  <p:cSld>
+    <p:spTree>
+      <p:nvGrpSpPr>
+        <p:cNvPr id="1" name="">
+          <a:extLst>
+            <a:ext uri="{FF2B5EF4-FFF2-40B4-BE49-F238E27FC236}">
+              <a16:creationId xmlns:a16="http://schemas.microsoft.com/office/drawing/2014/main" id="{CD34DC99-277A-BCB6-611C-7ECD6C1E163F}"/>
+            </a:ext>
+          </a:extLst>
+        </p:cNvPr>
+        <p:cNvGrpSpPr/>
+        <p:nvPr/>
+      </p:nvGrpSpPr>
+      <p:grpSpPr>
+        <a:xfrm>
+          <a:off x="0" y="0"/>
+          <a:ext cx="0" cy="0"/>
+          <a:chOff x="0" y="0"/>
+          <a:chExt cx="0" cy="0"/>
+        </a:xfrm>
+      </p:grpSpPr>
+      <p:sp>
+        <p:nvSpPr>
+          <p:cNvPr id="3" name="TextBox 2">
+            <a:extLst>
+              <a:ext uri="{FF2B5EF4-FFF2-40B4-BE49-F238E27FC236}">
+                <a16:creationId xmlns:a16="http://schemas.microsoft.com/office/drawing/2014/main" id="{938EF9E1-9CF0-1C14-CB19-52ABCE91359F}"/>
+              </a:ext>
+            </a:extLst>
+          </p:cNvPr>
+          <p:cNvSpPr txBox="1"/>
+          <p:nvPr/>
+        </p:nvSpPr>
+        <p:spPr>
+          <a:xfrm>
+            <a:off x="217714" y="255046"/>
+            <a:ext cx="11756571" cy="355354"/>
+          </a:xfrm>
+          <a:prstGeom prst="rect">
+            <a:avLst/>
+          </a:prstGeom>
+          <a:noFill/>
+        </p:spPr>
+        <p:txBody>
+          <a:bodyPr wrap="square">
+            <a:spAutoFit/>
+          </a:bodyPr>
+          <a:lstStyle/>
+          <a:p>
+            <a:pPr>
+              <a:lnSpc>
+                <a:spcPct val="150000"/>
+              </a:lnSpc>
+              <a:buNone/>
+            </a:pPr>
+            <a:r>
+              <a:rPr kumimoji="0" lang="en-US" altLang="en-US" sz="1300" b="0" i="0" u="none" strike="noStrike" cap="none" normalizeH="0" baseline="0">
+                <a:ln>
+                  <a:noFill/>
+                </a:ln>
+                <a:solidFill>
+                  <a:schemeClr val="tx1"/>
+                </a:solidFill>
+                <a:effectLst/>
+                <a:latin typeface="Arial" panose="020B0604020202020204" pitchFamily="34" charset="0"/>
+              </a:rPr>
+              <a:t>.</a:t>
+            </a:r>
+          </a:p>
+        </p:txBody>
+      </p:sp>
+      <p:pic>
+        <p:nvPicPr>
+          <p:cNvPr id="4" name="Picture 3">
+            <a:extLst>
+              <a:ext uri="{FF2B5EF4-FFF2-40B4-BE49-F238E27FC236}">
+                <a16:creationId xmlns:a16="http://schemas.microsoft.com/office/drawing/2014/main" id="{E13F893A-645C-9C4F-C1C7-FBF85FCB8756}"/>
+              </a:ext>
+            </a:extLst>
+          </p:cNvPr>
+          <p:cNvPicPr>
+            <a:picLocks noChangeAspect="1"/>
+          </p:cNvPicPr>
+          <p:nvPr/>
+        </p:nvPicPr>
+        <p:blipFill>
+          <a:blip r:embed="rId2"/>
+          <a:stretch>
+            <a:fillRect/>
+          </a:stretch>
+        </p:blipFill>
+        <p:spPr>
+          <a:xfrm>
+            <a:off x="675517" y="2157235"/>
+            <a:ext cx="10840963" cy="2543530"/>
+          </a:xfrm>
+          <a:prstGeom prst="rect">
+            <a:avLst/>
+          </a:prstGeom>
+        </p:spPr>
+      </p:pic>
+    </p:spTree>
+    <p:extLst>
+      <p:ext uri="{BB962C8B-B14F-4D97-AF65-F5344CB8AC3E}">
+        <p14:creationId xmlns:p14="http://schemas.microsoft.com/office/powerpoint/2010/main" val="1575637795"/>
+      </p:ext>
+    </p:extLst>
+  </p:cSld>
+  <p:clrMapOvr>
+    <a:masterClrMapping/>
+  </p:clrMapOvr>
+</p:sld>
+</file>
+
+<file path=ppt/slides/slide3.xml><?xml version="1.0" encoding="utf-8"?>
+<p:sld xmlns:a="http://schemas.openxmlformats.org/drawingml/2006/main" xmlns:r="http://schemas.openxmlformats.org/officeDocument/2006/relationships" xmlns:p="http://schemas.openxmlformats.org/presentationml/2006/main">
+  <p:cSld>
+    <p:spTree>
+      <p:nvGrpSpPr>
+        <p:cNvPr id="1" name="">
+          <a:extLst>
+            <a:ext uri="{FF2B5EF4-FFF2-40B4-BE49-F238E27FC236}">
+              <a16:creationId xmlns:a16="http://schemas.microsoft.com/office/drawing/2014/main" id="{E0FB58A6-D131-6FA4-7D0A-43710C3528A2}"/>
+            </a:ext>
+          </a:extLst>
+        </p:cNvPr>
+        <p:cNvGrpSpPr/>
+        <p:nvPr/>
+      </p:nvGrpSpPr>
+      <p:grpSpPr>
+        <a:xfrm>
+          <a:off x="0" y="0"/>
+          <a:ext cx="0" cy="0"/>
+          <a:chOff x="0" y="0"/>
+          <a:chExt cx="0" cy="0"/>
+        </a:xfrm>
+      </p:grpSpPr>
+      <p:sp>
+        <p:nvSpPr>
+          <p:cNvPr id="3" name="TextBox 2">
+            <a:extLst>
+              <a:ext uri="{FF2B5EF4-FFF2-40B4-BE49-F238E27FC236}">
+                <a16:creationId xmlns:a16="http://schemas.microsoft.com/office/drawing/2014/main" id="{8829047F-D0B6-7311-469B-D566EC6625EE}"/>
+              </a:ext>
+            </a:extLst>
+          </p:cNvPr>
+          <p:cNvSpPr txBox="1"/>
+          <p:nvPr/>
+        </p:nvSpPr>
+        <p:spPr>
+          <a:xfrm>
+            <a:off x="125350" y="88191"/>
+            <a:ext cx="11756571" cy="955518"/>
+          </a:xfrm>
+          <a:prstGeom prst="rect">
+            <a:avLst/>
+          </a:prstGeom>
+          <a:noFill/>
+        </p:spPr>
+        <p:txBody>
+          <a:bodyPr wrap="square">
+            <a:spAutoFit/>
+          </a:bodyPr>
+          <a:lstStyle/>
+          <a:p>
+            <a:pPr>
+              <a:lnSpc>
+                <a:spcPct val="150000"/>
+              </a:lnSpc>
+              <a:buNone/>
+            </a:pPr>
+            <a:r>
+              <a:rPr kumimoji="0" lang="az-Latn-AZ" altLang="en-US" sz="1300" b="1" i="0" u="none" strike="noStrike" cap="none" normalizeH="0" baseline="0">
+                <a:ln>
+                  <a:noFill/>
+                </a:ln>
+                <a:solidFill>
+                  <a:schemeClr val="tx1"/>
+                </a:solidFill>
+                <a:effectLst/>
+                <a:latin typeface="Arial" panose="020B0604020202020204" pitchFamily="34" charset="0"/>
+              </a:rPr>
+              <a:t>İmage Gallery </a:t>
+            </a:r>
+            <a:r>
+              <a:rPr kumimoji="0" lang="az-Latn-AZ" altLang="en-US" sz="1300" b="0" i="0" u="none" strike="noStrike" cap="none" normalizeH="0" baseline="0">
+                <a:ln>
+                  <a:noFill/>
+                </a:ln>
+                <a:solidFill>
+                  <a:schemeClr val="tx1"/>
+                </a:solidFill>
+                <a:effectLst/>
+                <a:latin typeface="Arial" panose="020B0604020202020204" pitchFamily="34" charset="0"/>
+              </a:rPr>
+              <a:t>üçün ayrıca bir şablon yaradırıq.</a:t>
+            </a:r>
+          </a:p>
+          <a:p>
+            <a:pPr>
+              <a:lnSpc>
+                <a:spcPct val="150000"/>
+              </a:lnSpc>
+              <a:buNone/>
+            </a:pPr>
+            <a:endParaRPr lang="az-Latn-AZ" altLang="en-US" sz="1300">
+              <a:latin typeface="Arial" panose="020B0604020202020204" pitchFamily="34" charset="0"/>
+            </a:endParaRPr>
+          </a:p>
+          <a:p>
+            <a:pPr>
+              <a:lnSpc>
+                <a:spcPct val="150000"/>
+              </a:lnSpc>
+              <a:buNone/>
+            </a:pPr>
+            <a:r>
+              <a:rPr kumimoji="0" lang="az-Latn-AZ" altLang="en-US" sz="1300" b="0" i="0" u="none" strike="noStrike" cap="none" normalizeH="0" baseline="0">
+                <a:ln>
+                  <a:noFill/>
+                </a:ln>
+                <a:solidFill>
+                  <a:schemeClr val="tx1"/>
+                </a:solidFill>
+                <a:effectLst/>
+                <a:latin typeface="Arial" panose="020B0604020202020204" pitchFamily="34" charset="0"/>
+              </a:rPr>
+              <a:t>Hər </a:t>
+            </a:r>
+            <a:r>
+              <a:rPr kumimoji="0" lang="az-Latn-AZ" altLang="en-US" sz="1300" b="1" i="0" u="none" strike="noStrike" cap="none" normalizeH="0" baseline="0">
+                <a:ln>
+                  <a:noFill/>
+                </a:ln>
+                <a:solidFill>
+                  <a:schemeClr val="tx1"/>
+                </a:solidFill>
+                <a:effectLst/>
+                <a:latin typeface="Arial" panose="020B0604020202020204" pitchFamily="34" charset="0"/>
+              </a:rPr>
+              <a:t>product</a:t>
+            </a:r>
+            <a:r>
+              <a:rPr kumimoji="0" lang="az-Latn-AZ" altLang="en-US" sz="1300" b="0" i="0" u="none" strike="noStrike" cap="none" normalizeH="0" baseline="0">
+                <a:ln>
+                  <a:noFill/>
+                </a:ln>
+                <a:solidFill>
+                  <a:schemeClr val="tx1"/>
+                </a:solidFill>
+                <a:effectLst/>
+                <a:latin typeface="Arial" panose="020B0604020202020204" pitchFamily="34" charset="0"/>
+              </a:rPr>
+              <a:t> üçün əlavə edəcəyimiz </a:t>
+            </a:r>
+            <a:r>
+              <a:rPr kumimoji="0" lang="az-Latn-AZ" altLang="en-US" sz="1300" b="1" i="0" u="none" strike="noStrike" cap="none" normalizeH="0" baseline="0">
+                <a:ln>
+                  <a:noFill/>
+                </a:ln>
+                <a:solidFill>
+                  <a:schemeClr val="tx1"/>
+                </a:solidFill>
+                <a:effectLst/>
+                <a:latin typeface="Arial" panose="020B0604020202020204" pitchFamily="34" charset="0"/>
+              </a:rPr>
+              <a:t>çoxlu şəkillər </a:t>
+            </a:r>
+            <a:r>
+              <a:rPr kumimoji="0" lang="az-Latn-AZ" altLang="en-US" sz="1300" b="0" i="0" u="none" strike="noStrike" cap="none" normalizeH="0" baseline="0">
+                <a:ln>
+                  <a:noFill/>
+                </a:ln>
+                <a:solidFill>
+                  <a:schemeClr val="tx1"/>
+                </a:solidFill>
+                <a:effectLst/>
+                <a:latin typeface="Arial" panose="020B0604020202020204" pitchFamily="34" charset="0"/>
+              </a:rPr>
+              <a:t>həmin </a:t>
+            </a:r>
+            <a:r>
+              <a:rPr kumimoji="0" lang="az-Latn-AZ" altLang="en-US" sz="1300" b="1" i="0" u="none" strike="noStrike" cap="none" normalizeH="0" baseline="0">
+                <a:ln>
+                  <a:noFill/>
+                </a:ln>
+                <a:solidFill>
+                  <a:schemeClr val="tx1"/>
+                </a:solidFill>
+                <a:effectLst/>
+                <a:latin typeface="Arial" panose="020B0604020202020204" pitchFamily="34" charset="0"/>
+              </a:rPr>
+              <a:t>bu şablon </a:t>
+            </a:r>
+            <a:r>
+              <a:rPr kumimoji="0" lang="az-Latn-AZ" altLang="en-US" sz="1300" b="0" i="0" u="none" strike="noStrike" cap="none" normalizeH="0" baseline="0">
+                <a:ln>
+                  <a:noFill/>
+                </a:ln>
+                <a:solidFill>
+                  <a:schemeClr val="tx1"/>
+                </a:solidFill>
+                <a:effectLst/>
+                <a:latin typeface="Arial" panose="020B0604020202020204" pitchFamily="34" charset="0"/>
+              </a:rPr>
+              <a:t>vasitəsi ilə seçəcəyik.</a:t>
+            </a:r>
+            <a:endParaRPr kumimoji="0" lang="en-US" altLang="en-US" sz="1300" b="0" i="0" u="none" strike="noStrike" cap="none" normalizeH="0" baseline="0">
+              <a:ln>
+                <a:noFill/>
+              </a:ln>
+              <a:solidFill>
+                <a:schemeClr val="tx1"/>
+              </a:solidFill>
+              <a:effectLst/>
+              <a:latin typeface="Arial" panose="020B0604020202020204" pitchFamily="34" charset="0"/>
+            </a:endParaRPr>
+          </a:p>
+        </p:txBody>
+      </p:sp>
+      <p:pic>
+        <p:nvPicPr>
+          <p:cNvPr id="4" name="Picture 3">
+            <a:extLst>
+              <a:ext uri="{FF2B5EF4-FFF2-40B4-BE49-F238E27FC236}">
+                <a16:creationId xmlns:a16="http://schemas.microsoft.com/office/drawing/2014/main" id="{B30035CF-A9F8-5136-D11F-C0821B319991}"/>
+              </a:ext>
+            </a:extLst>
+          </p:cNvPr>
+          <p:cNvPicPr>
+            <a:picLocks noChangeAspect="1"/>
+          </p:cNvPicPr>
+          <p:nvPr/>
+        </p:nvPicPr>
+        <p:blipFill>
+          <a:blip r:embed="rId2"/>
+          <a:stretch>
+            <a:fillRect/>
+          </a:stretch>
+        </p:blipFill>
+        <p:spPr>
+          <a:xfrm>
+            <a:off x="4038142" y="1126836"/>
+            <a:ext cx="8153857" cy="5731164"/>
+          </a:xfrm>
+          <a:prstGeom prst="rect">
+            <a:avLst/>
+          </a:prstGeom>
+        </p:spPr>
+      </p:pic>
+    </p:spTree>
+    <p:extLst>
+      <p:ext uri="{BB962C8B-B14F-4D97-AF65-F5344CB8AC3E}">
+        <p14:creationId xmlns:p14="http://schemas.microsoft.com/office/powerpoint/2010/main" val="2144391829"/>
+      </p:ext>
+    </p:extLst>
+  </p:cSld>
+  <p:clrMapOvr>
+    <a:masterClrMapping/>
+  </p:clrMapOvr>
+</p:sld>
+</file>
+
+<file path=ppt/slides/slide4.xml><?xml version="1.0" encoding="utf-8"?>
 <p:sld xmlns:a="http://schemas.openxmlformats.org/drawingml/2006/main" xmlns:r="http://schemas.openxmlformats.org/officeDocument/2006/relationships" xmlns:p="http://schemas.openxmlformats.org/presentationml/2006/main">
   <p:cSld>
     <p:spTree>
@@ -3434,8 +4214,8 @@
         </p:nvSpPr>
         <p:spPr>
           <a:xfrm>
-            <a:off x="217714" y="255046"/>
-            <a:ext cx="11756571" cy="355354"/>
+            <a:off x="0" y="107264"/>
+            <a:ext cx="12192000" cy="1555682"/>
           </a:xfrm>
           <a:prstGeom prst="rect">
             <a:avLst/>
@@ -3455,21 +4235,209 @@
               <a:buNone/>
             </a:pPr>
             <a:r>
-              <a:rPr kumimoji="0" lang="en-US" altLang="en-US" sz="1300" b="0" i="0" u="none" strike="noStrike" cap="none" normalizeH="0" baseline="0">
-                <a:ln>
-                  <a:noFill/>
-                </a:ln>
-                <a:solidFill>
-                  <a:schemeClr val="tx1"/>
-                </a:solidFill>
-                <a:effectLst/>
+              <a:rPr lang="en-US" altLang="en-US" sz="1300" b="1">
                 <a:latin typeface="Arial" panose="020B0604020202020204" pitchFamily="34" charset="0"/>
               </a:rPr>
-              <a:t>.</a:t>
-            </a:r>
-          </a:p>
-        </p:txBody>
-      </p:sp>
+              <a:t>app\Http\Controllers\Backend\ProductImageGalleryController.php</a:t>
+            </a:r>
+            <a:r>
+              <a:rPr lang="ru-RU" altLang="en-US" sz="1300" b="1">
+                <a:latin typeface="Arial" panose="020B0604020202020204" pitchFamily="34" charset="0"/>
+              </a:rPr>
+              <a:t> </a:t>
+            </a:r>
+            <a:r>
+              <a:rPr lang="ru-RU" altLang="en-US" sz="1300">
+                <a:latin typeface="Arial" panose="020B0604020202020204" pitchFamily="34" charset="0"/>
+              </a:rPr>
+              <a:t>- </a:t>
+            </a:r>
+            <a:r>
+              <a:rPr lang="en-US" altLang="en-US" sz="1300" i="1">
+                <a:solidFill>
+                  <a:srgbClr val="00B050"/>
+                </a:solidFill>
+                <a:latin typeface="Arial" panose="020B0604020202020204" pitchFamily="34" charset="0"/>
+              </a:rPr>
+              <a:t>index</a:t>
+            </a:r>
+            <a:r>
+              <a:rPr lang="en-US" altLang="en-US" sz="1300">
+                <a:latin typeface="Arial" panose="020B0604020202020204" pitchFamily="34" charset="0"/>
+              </a:rPr>
+              <a:t> meotdunu yazaraq </a:t>
+            </a:r>
+            <a:r>
+              <a:rPr lang="en-US" altLang="en-US" sz="1300" b="1">
+                <a:latin typeface="Arial" panose="020B0604020202020204" pitchFamily="34" charset="0"/>
+              </a:rPr>
+              <a:t>ImageGallery</a:t>
+            </a:r>
+            <a:r>
+              <a:rPr lang="en-US" altLang="en-US" sz="1300">
+                <a:latin typeface="Arial" panose="020B0604020202020204" pitchFamily="34" charset="0"/>
+              </a:rPr>
+              <a:t> </a:t>
+            </a:r>
+            <a:r>
+              <a:rPr lang="az-Latn-AZ" altLang="en-US" sz="1300">
+                <a:latin typeface="Arial" panose="020B0604020202020204" pitchFamily="34" charset="0"/>
+              </a:rPr>
+              <a:t>ş</a:t>
+            </a:r>
+            <a:r>
+              <a:rPr lang="en-US" altLang="en-US" sz="1300">
+                <a:latin typeface="Arial" panose="020B0604020202020204" pitchFamily="34" charset="0"/>
+              </a:rPr>
+              <a:t>ablonumuzu</a:t>
+            </a:r>
+            <a:r>
+              <a:rPr lang="az-Latn-AZ" altLang="en-US" sz="1300">
+                <a:latin typeface="Arial" panose="020B0604020202020204" pitchFamily="34" charset="0"/>
+              </a:rPr>
+              <a:t> görüntüləyirik. Product -a aid məlumatları göstərmək üçün isə, </a:t>
+            </a:r>
+            <a:r>
+              <a:rPr lang="en-US" altLang="en-US" sz="1300" b="1">
+                <a:latin typeface="Arial" panose="020B0604020202020204" pitchFamily="34" charset="0"/>
+              </a:rPr>
+              <a:t>ProductDataTable</a:t>
+            </a:r>
+            <a:r>
+              <a:rPr lang="en-US" altLang="en-US" sz="1300">
+                <a:latin typeface="Arial" panose="020B0604020202020204" pitchFamily="34" charset="0"/>
+              </a:rPr>
+              <a:t> -</a:t>
+            </a:r>
+            <a:r>
+              <a:rPr lang="az-Latn-AZ" altLang="en-US" sz="1300">
+                <a:latin typeface="Arial" panose="020B0604020202020204" pitchFamily="34" charset="0"/>
+              </a:rPr>
+              <a:t>ından, </a:t>
+            </a:r>
+            <a:r>
+              <a:rPr lang="az-Latn-AZ" altLang="en-US" sz="1300" b="1">
+                <a:latin typeface="Arial" panose="020B0604020202020204" pitchFamily="34" charset="0"/>
+              </a:rPr>
+              <a:t>Product</a:t>
+            </a:r>
+            <a:r>
+              <a:rPr lang="az-Latn-AZ" altLang="en-US" sz="1300">
+                <a:latin typeface="Arial" panose="020B0604020202020204" pitchFamily="34" charset="0"/>
+              </a:rPr>
+              <a:t> identifikatorunu </a:t>
+            </a:r>
+            <a:r>
+              <a:rPr lang="en-US" altLang="en-US" sz="1300" b="1">
+                <a:latin typeface="Arial" panose="020B0604020202020204" pitchFamily="34" charset="0"/>
+              </a:rPr>
+              <a:t>ProductImageGalleryController </a:t>
+            </a:r>
+            <a:r>
+              <a:rPr lang="az-Latn-AZ" altLang="en-US" sz="1300">
+                <a:latin typeface="Arial" panose="020B0604020202020204" pitchFamily="34" charset="0"/>
+              </a:rPr>
+              <a:t>-ə</a:t>
+            </a:r>
+            <a:r>
+              <a:rPr lang="az-Latn-AZ" altLang="en-US" sz="1300" b="1">
+                <a:latin typeface="Arial" panose="020B0604020202020204" pitchFamily="34" charset="0"/>
+              </a:rPr>
+              <a:t> </a:t>
+            </a:r>
+            <a:r>
+              <a:rPr lang="az-Latn-AZ" altLang="en-US" sz="1300">
+                <a:latin typeface="Arial" panose="020B0604020202020204" pitchFamily="34" charset="0"/>
+              </a:rPr>
+              <a:t>göndəririk ki, həmin identifikator ilə məhsulu əldə edə bilək.</a:t>
+            </a:r>
+          </a:p>
+          <a:p>
+            <a:pPr>
+              <a:lnSpc>
+                <a:spcPct val="150000"/>
+              </a:lnSpc>
+              <a:buNone/>
+            </a:pPr>
+            <a:endParaRPr kumimoji="0" lang="az-Latn-AZ" altLang="en-US" sz="1300" b="0" i="0" u="none" strike="noStrike" cap="none" normalizeH="0" baseline="0">
+              <a:ln>
+                <a:noFill/>
+              </a:ln>
+              <a:solidFill>
+                <a:schemeClr val="tx1"/>
+              </a:solidFill>
+              <a:effectLst/>
+              <a:latin typeface="Arial" panose="020B0604020202020204" pitchFamily="34" charset="0"/>
+            </a:endParaRPr>
+          </a:p>
+          <a:p>
+            <a:pPr>
+              <a:lnSpc>
+                <a:spcPct val="150000"/>
+              </a:lnSpc>
+              <a:buNone/>
+            </a:pPr>
+            <a:r>
+              <a:rPr lang="az-Latn-AZ" altLang="en-US" sz="1300">
+                <a:latin typeface="Arial" panose="020B0604020202020204" pitchFamily="34" charset="0"/>
+              </a:rPr>
+              <a:t>Çünki seçilən məhsul haqqında </a:t>
+            </a:r>
+            <a:r>
+              <a:rPr lang="en-US" altLang="en-US" sz="1300" b="1">
+                <a:latin typeface="Arial" panose="020B0604020202020204" pitchFamily="34" charset="0"/>
+              </a:rPr>
+              <a:t>ProductImageGalleryController </a:t>
+            </a:r>
+            <a:r>
+              <a:rPr lang="az-Latn-AZ" altLang="en-US" sz="1300">
+                <a:latin typeface="Arial" panose="020B0604020202020204" pitchFamily="34" charset="0"/>
+              </a:rPr>
+              <a:t>-də məlumat göstərmək istəyirik.</a:t>
+            </a:r>
+            <a:endParaRPr kumimoji="0" lang="en-US" altLang="en-US" sz="1300" b="0" i="0" u="none" strike="noStrike" cap="none" normalizeH="0" baseline="0">
+              <a:ln>
+                <a:noFill/>
+              </a:ln>
+              <a:solidFill>
+                <a:schemeClr val="tx1"/>
+              </a:solidFill>
+              <a:effectLst/>
+              <a:latin typeface="Arial" panose="020B0604020202020204" pitchFamily="34" charset="0"/>
+            </a:endParaRPr>
+          </a:p>
+        </p:txBody>
+      </p:sp>
+      <p:pic>
+        <p:nvPicPr>
+          <p:cNvPr id="4" name="Picture 3">
+            <a:extLst>
+              <a:ext uri="{FF2B5EF4-FFF2-40B4-BE49-F238E27FC236}">
+                <a16:creationId xmlns:a16="http://schemas.microsoft.com/office/drawing/2014/main" id="{750AFAB4-E6DF-F521-C984-E6B01FD4BA61}"/>
+              </a:ext>
+            </a:extLst>
+          </p:cNvPr>
+          <p:cNvPicPr>
+            <a:picLocks noChangeAspect="1"/>
+          </p:cNvPicPr>
+          <p:nvPr/>
+        </p:nvPicPr>
+        <p:blipFill>
+          <a:blip r:embed="rId2"/>
+          <a:stretch>
+            <a:fillRect/>
+          </a:stretch>
+        </p:blipFill>
+        <p:spPr>
+          <a:xfrm>
+            <a:off x="4193309" y="2048172"/>
+            <a:ext cx="7998691" cy="4809828"/>
+          </a:xfrm>
+          <a:prstGeom prst="rect">
+            <a:avLst/>
+          </a:prstGeom>
+        </p:spPr>
+      </p:pic>
     </p:spTree>
     <p:extLst>
       <p:ext uri="{BB962C8B-B14F-4D97-AF65-F5344CB8AC3E}">
@@ -3483,7 +4451,523 @@
 </p:sld>
 </file>
 
-<file path=ppt/slides/slide3.xml><?xml version="1.0" encoding="utf-8"?>
+<file path=ppt/slides/slide5.xml><?xml version="1.0" encoding="utf-8"?>
+<p:sld xmlns:a="http://schemas.openxmlformats.org/drawingml/2006/main" xmlns:r="http://schemas.openxmlformats.org/officeDocument/2006/relationships" xmlns:p="http://schemas.openxmlformats.org/presentationml/2006/main">
+  <p:cSld>
+    <p:spTree>
+      <p:nvGrpSpPr>
+        <p:cNvPr id="1" name="">
+          <a:extLst>
+            <a:ext uri="{FF2B5EF4-FFF2-40B4-BE49-F238E27FC236}">
+              <a16:creationId xmlns:a16="http://schemas.microsoft.com/office/drawing/2014/main" id="{EEABFC43-7601-117B-5B84-91C0D7072793}"/>
+            </a:ext>
+          </a:extLst>
+        </p:cNvPr>
+        <p:cNvGrpSpPr/>
+        <p:nvPr/>
+      </p:nvGrpSpPr>
+      <p:grpSpPr>
+        <a:xfrm>
+          <a:off x="0" y="0"/>
+          <a:ext cx="0" cy="0"/>
+          <a:chOff x="0" y="0"/>
+          <a:chExt cx="0" cy="0"/>
+        </a:xfrm>
+      </p:grpSpPr>
+      <p:sp>
+        <p:nvSpPr>
+          <p:cNvPr id="3" name="TextBox 2">
+            <a:extLst>
+              <a:ext uri="{FF2B5EF4-FFF2-40B4-BE49-F238E27FC236}">
+                <a16:creationId xmlns:a16="http://schemas.microsoft.com/office/drawing/2014/main" id="{D509BA9F-902B-17D8-8C62-63B4565F1EBB}"/>
+              </a:ext>
+            </a:extLst>
+          </p:cNvPr>
+          <p:cNvSpPr txBox="1"/>
+          <p:nvPr/>
+        </p:nvSpPr>
+        <p:spPr>
+          <a:xfrm>
+            <a:off x="217714" y="255046"/>
+            <a:ext cx="11756571" cy="955518"/>
+          </a:xfrm>
+          <a:prstGeom prst="rect">
+            <a:avLst/>
+          </a:prstGeom>
+          <a:noFill/>
+        </p:spPr>
+        <p:txBody>
+          <a:bodyPr wrap="square">
+            <a:spAutoFit/>
+          </a:bodyPr>
+          <a:lstStyle/>
+          <a:p>
+            <a:pPr>
+              <a:lnSpc>
+                <a:spcPct val="150000"/>
+              </a:lnSpc>
+              <a:buNone/>
+            </a:pPr>
+            <a:r>
+              <a:rPr lang="az-Latn-AZ" altLang="en-US" sz="1300">
+                <a:latin typeface="Arial" panose="020B0604020202020204" pitchFamily="34" charset="0"/>
+              </a:rPr>
+              <a:t>İmage Galery düyməsini klikləyərək şablona keçid edirik. </a:t>
+            </a:r>
+          </a:p>
+          <a:p>
+            <a:pPr>
+              <a:lnSpc>
+                <a:spcPct val="150000"/>
+              </a:lnSpc>
+              <a:buNone/>
+            </a:pPr>
+            <a:endParaRPr kumimoji="0" lang="az-Latn-AZ" altLang="en-US" sz="1300" b="0" i="0" u="none" strike="noStrike" cap="none" normalizeH="0" baseline="0">
+              <a:ln>
+                <a:noFill/>
+              </a:ln>
+              <a:solidFill>
+                <a:schemeClr val="tx1"/>
+              </a:solidFill>
+              <a:effectLst/>
+              <a:latin typeface="Arial" panose="020B0604020202020204" pitchFamily="34" charset="0"/>
+            </a:endParaRPr>
+          </a:p>
+          <a:p>
+            <a:pPr>
+              <a:lnSpc>
+                <a:spcPct val="150000"/>
+              </a:lnSpc>
+              <a:buNone/>
+            </a:pPr>
+            <a:r>
+              <a:rPr lang="az-Latn-AZ" altLang="en-US" sz="1300">
+                <a:latin typeface="Arial" panose="020B0604020202020204" pitchFamily="34" charset="0"/>
+              </a:rPr>
+              <a:t>Şablon tam hazır olmadığı üçün hələki xətalar görürük. Məsələn, hələki </a:t>
+            </a:r>
+            <a:r>
+              <a:rPr lang="az-Latn-AZ" altLang="en-US" sz="1300" b="1">
+                <a:latin typeface="Arial" panose="020B0604020202020204" pitchFamily="34" charset="0"/>
+              </a:rPr>
+              <a:t>DB</a:t>
+            </a:r>
+            <a:r>
+              <a:rPr lang="az-Latn-AZ" altLang="en-US" sz="1300">
+                <a:latin typeface="Arial" panose="020B0604020202020204" pitchFamily="34" charset="0"/>
+              </a:rPr>
+              <a:t> hazır deyil.</a:t>
+            </a:r>
+            <a:endParaRPr kumimoji="0" lang="en-US" altLang="en-US" sz="1300" b="0" i="0" u="none" strike="noStrike" cap="none" normalizeH="0" baseline="0">
+              <a:ln>
+                <a:noFill/>
+              </a:ln>
+              <a:solidFill>
+                <a:schemeClr val="tx1"/>
+              </a:solidFill>
+              <a:effectLst/>
+              <a:latin typeface="Arial" panose="020B0604020202020204" pitchFamily="34" charset="0"/>
+            </a:endParaRPr>
+          </a:p>
+        </p:txBody>
+      </p:sp>
+      <p:grpSp>
+        <p:nvGrpSpPr>
+          <p:cNvPr id="7" name="Group 6">
+            <a:extLst>
+              <a:ext uri="{FF2B5EF4-FFF2-40B4-BE49-F238E27FC236}">
+                <a16:creationId xmlns:a16="http://schemas.microsoft.com/office/drawing/2014/main" id="{7A73CE3C-0A1F-5134-727D-D8432EC93286}"/>
+              </a:ext>
+            </a:extLst>
+          </p:cNvPr>
+          <p:cNvGrpSpPr/>
+          <p:nvPr/>
+        </p:nvGrpSpPr>
+        <p:grpSpPr>
+          <a:xfrm>
+            <a:off x="7649332" y="165494"/>
+            <a:ext cx="4324953" cy="1579380"/>
+            <a:chOff x="473119" y="2114367"/>
+            <a:chExt cx="4324953" cy="1579380"/>
+          </a:xfrm>
+        </p:grpSpPr>
+        <p:pic>
+          <p:nvPicPr>
+            <p:cNvPr id="4" name="Picture 3">
+              <a:extLst>
+                <a:ext uri="{FF2B5EF4-FFF2-40B4-BE49-F238E27FC236}">
+                  <a16:creationId xmlns:a16="http://schemas.microsoft.com/office/drawing/2014/main" id="{A77E0833-B033-17FA-59D0-AB984F572E45}"/>
+                </a:ext>
+              </a:extLst>
+            </p:cNvPr>
+            <p:cNvPicPr>
+              <a:picLocks noChangeAspect="1"/>
+            </p:cNvPicPr>
+            <p:nvPr/>
+          </p:nvPicPr>
+          <p:blipFill>
+            <a:blip r:embed="rId2"/>
+            <a:stretch>
+              <a:fillRect/>
+            </a:stretch>
+          </p:blipFill>
+          <p:spPr>
+            <a:xfrm>
+              <a:off x="2225963" y="2114367"/>
+              <a:ext cx="2572109" cy="1314633"/>
+            </a:xfrm>
+            <a:prstGeom prst="rect">
+              <a:avLst/>
+            </a:prstGeom>
+            <a:ln w="38100" cap="sq">
+              <a:solidFill>
+                <a:srgbClr val="000000"/>
+              </a:solidFill>
+              <a:prstDash val="solid"/>
+              <a:miter lim="800000"/>
+            </a:ln>
+            <a:effectLst>
+              <a:outerShdw blurRad="50800" dist="38100" dir="2700000" algn="tl" rotWithShape="0">
+                <a:srgbClr val="000000">
+                  <a:alpha val="43000"/>
+                </a:srgbClr>
+              </a:outerShdw>
+            </a:effectLst>
+          </p:spPr>
+        </p:pic>
+        <p:pic>
+          <p:nvPicPr>
+            <p:cNvPr id="6" name="Picture 5">
+              <a:extLst>
+                <a:ext uri="{FF2B5EF4-FFF2-40B4-BE49-F238E27FC236}">
+                  <a16:creationId xmlns:a16="http://schemas.microsoft.com/office/drawing/2014/main" id="{7D3F2EB6-2313-AAD0-43F9-B9B71472F62F}"/>
+                </a:ext>
+              </a:extLst>
+            </p:cNvPr>
+            <p:cNvPicPr>
+              <a:picLocks noChangeAspect="1"/>
+            </p:cNvPicPr>
+            <p:nvPr/>
+          </p:nvPicPr>
+          <p:blipFill>
+            <a:blip r:embed="rId3"/>
+            <a:stretch>
+              <a:fillRect/>
+            </a:stretch>
+          </p:blipFill>
+          <p:spPr>
+            <a:xfrm>
+              <a:off x="473119" y="3493694"/>
+              <a:ext cx="3505689" cy="200053"/>
+            </a:xfrm>
+            <a:prstGeom prst="rect">
+              <a:avLst/>
+            </a:prstGeom>
+          </p:spPr>
+        </p:pic>
+      </p:grpSp>
+      <p:pic>
+        <p:nvPicPr>
+          <p:cNvPr id="9" name="Picture 8">
+            <a:extLst>
+              <a:ext uri="{FF2B5EF4-FFF2-40B4-BE49-F238E27FC236}">
+                <a16:creationId xmlns:a16="http://schemas.microsoft.com/office/drawing/2014/main" id="{D661A1F7-C538-9C7E-A28A-DC837748C18F}"/>
+              </a:ext>
+            </a:extLst>
+          </p:cNvPr>
+          <p:cNvPicPr>
+            <a:picLocks noChangeAspect="1"/>
+          </p:cNvPicPr>
+          <p:nvPr/>
+        </p:nvPicPr>
+        <p:blipFill>
+          <a:blip r:embed="rId4"/>
+          <a:stretch>
+            <a:fillRect/>
+          </a:stretch>
+        </p:blipFill>
+        <p:spPr>
+          <a:xfrm>
+            <a:off x="0" y="2637867"/>
+            <a:ext cx="8298088" cy="4220133"/>
+          </a:xfrm>
+          <a:prstGeom prst="rect">
+            <a:avLst/>
+          </a:prstGeom>
+        </p:spPr>
+      </p:pic>
+    </p:spTree>
+    <p:extLst>
+      <p:ext uri="{BB962C8B-B14F-4D97-AF65-F5344CB8AC3E}">
+        <p14:creationId xmlns:p14="http://schemas.microsoft.com/office/powerpoint/2010/main" val="3968592772"/>
+      </p:ext>
+    </p:extLst>
+  </p:cSld>
+  <p:clrMapOvr>
+    <a:masterClrMapping/>
+  </p:clrMapOvr>
+</p:sld>
+</file>
+
+<file path=ppt/slides/slide6.xml><?xml version="1.0" encoding="utf-8"?>
+<p:sld xmlns:a="http://schemas.openxmlformats.org/drawingml/2006/main" xmlns:r="http://schemas.openxmlformats.org/officeDocument/2006/relationships" xmlns:p="http://schemas.openxmlformats.org/presentationml/2006/main">
+  <p:cSld>
+    <p:spTree>
+      <p:nvGrpSpPr>
+        <p:cNvPr id="1" name="">
+          <a:extLst>
+            <a:ext uri="{FF2B5EF4-FFF2-40B4-BE49-F238E27FC236}">
+              <a16:creationId xmlns:a16="http://schemas.microsoft.com/office/drawing/2014/main" id="{2C6093D3-55E9-557A-3E35-A6C600160C02}"/>
+            </a:ext>
+          </a:extLst>
+        </p:cNvPr>
+        <p:cNvGrpSpPr/>
+        <p:nvPr/>
+      </p:nvGrpSpPr>
+      <p:grpSpPr>
+        <a:xfrm>
+          <a:off x="0" y="0"/>
+          <a:ext cx="0" cy="0"/>
+          <a:chOff x="0" y="0"/>
+          <a:chExt cx="0" cy="0"/>
+        </a:xfrm>
+      </p:grpSpPr>
+      <p:sp>
+        <p:nvSpPr>
+          <p:cNvPr id="3" name="TextBox 2">
+            <a:extLst>
+              <a:ext uri="{FF2B5EF4-FFF2-40B4-BE49-F238E27FC236}">
+                <a16:creationId xmlns:a16="http://schemas.microsoft.com/office/drawing/2014/main" id="{C76B7976-5A69-A656-4C58-96D3B72DAF17}"/>
+              </a:ext>
+            </a:extLst>
+          </p:cNvPr>
+          <p:cNvSpPr txBox="1"/>
+          <p:nvPr/>
+        </p:nvSpPr>
+        <p:spPr>
+          <a:xfrm>
+            <a:off x="217714" y="255046"/>
+            <a:ext cx="11756571" cy="355354"/>
+          </a:xfrm>
+          <a:prstGeom prst="rect">
+            <a:avLst/>
+          </a:prstGeom>
+          <a:noFill/>
+        </p:spPr>
+        <p:txBody>
+          <a:bodyPr wrap="square">
+            <a:spAutoFit/>
+          </a:bodyPr>
+          <a:lstStyle/>
+          <a:p>
+            <a:pPr>
+              <a:lnSpc>
+                <a:spcPct val="150000"/>
+              </a:lnSpc>
+              <a:buNone/>
+            </a:pPr>
+            <a:r>
+              <a:rPr kumimoji="0" lang="en-US" altLang="en-US" sz="1300" b="0" i="0" u="none" strike="noStrike" cap="none" normalizeH="0" baseline="0">
+                <a:ln>
+                  <a:noFill/>
+                </a:ln>
+                <a:solidFill>
+                  <a:schemeClr val="tx1"/>
+                </a:solidFill>
+                <a:effectLst/>
+                <a:latin typeface="Arial" panose="020B0604020202020204" pitchFamily="34" charset="0"/>
+              </a:rPr>
+              <a:t>.</a:t>
+            </a:r>
+          </a:p>
+        </p:txBody>
+      </p:sp>
+    </p:spTree>
+    <p:extLst>
+      <p:ext uri="{BB962C8B-B14F-4D97-AF65-F5344CB8AC3E}">
+        <p14:creationId xmlns:p14="http://schemas.microsoft.com/office/powerpoint/2010/main" val="937783240"/>
+      </p:ext>
+    </p:extLst>
+  </p:cSld>
+  <p:clrMapOvr>
+    <a:masterClrMapping/>
+  </p:clrMapOvr>
+</p:sld>
+</file>
+
+<file path=ppt/slides/slide7.xml><?xml version="1.0" encoding="utf-8"?>
+<p:sld xmlns:a="http://schemas.openxmlformats.org/drawingml/2006/main" xmlns:r="http://schemas.openxmlformats.org/officeDocument/2006/relationships" xmlns:p="http://schemas.openxmlformats.org/presentationml/2006/main">
+  <p:cSld>
+    <p:spTree>
+      <p:nvGrpSpPr>
+        <p:cNvPr id="1" name="">
+          <a:extLst>
+            <a:ext uri="{FF2B5EF4-FFF2-40B4-BE49-F238E27FC236}">
+              <a16:creationId xmlns:a16="http://schemas.microsoft.com/office/drawing/2014/main" id="{68D5096E-3CA7-7D45-9D59-CEE027CD8ADB}"/>
+            </a:ext>
+          </a:extLst>
+        </p:cNvPr>
+        <p:cNvGrpSpPr/>
+        <p:nvPr/>
+      </p:nvGrpSpPr>
+      <p:grpSpPr>
+        <a:xfrm>
+          <a:off x="0" y="0"/>
+          <a:ext cx="0" cy="0"/>
+          <a:chOff x="0" y="0"/>
+          <a:chExt cx="0" cy="0"/>
+        </a:xfrm>
+      </p:grpSpPr>
+      <p:sp>
+        <p:nvSpPr>
+          <p:cNvPr id="3" name="TextBox 2">
+            <a:extLst>
+              <a:ext uri="{FF2B5EF4-FFF2-40B4-BE49-F238E27FC236}">
+                <a16:creationId xmlns:a16="http://schemas.microsoft.com/office/drawing/2014/main" id="{0D06B011-B24B-A22B-1B97-822BD698D4A9}"/>
+              </a:ext>
+            </a:extLst>
+          </p:cNvPr>
+          <p:cNvSpPr txBox="1"/>
+          <p:nvPr/>
+        </p:nvSpPr>
+        <p:spPr>
+          <a:xfrm>
+            <a:off x="217714" y="255046"/>
+            <a:ext cx="11756571" cy="355354"/>
+          </a:xfrm>
+          <a:prstGeom prst="rect">
+            <a:avLst/>
+          </a:prstGeom>
+          <a:noFill/>
+        </p:spPr>
+        <p:txBody>
+          <a:bodyPr wrap="square">
+            <a:spAutoFit/>
+          </a:bodyPr>
+          <a:lstStyle/>
+          <a:p>
+            <a:pPr>
+              <a:lnSpc>
+                <a:spcPct val="150000"/>
+              </a:lnSpc>
+              <a:buNone/>
+            </a:pPr>
+            <a:r>
+              <a:rPr kumimoji="0" lang="en-US" altLang="en-US" sz="1300" b="0" i="0" u="none" strike="noStrike" cap="none" normalizeH="0" baseline="0">
+                <a:ln>
+                  <a:noFill/>
+                </a:ln>
+                <a:solidFill>
+                  <a:schemeClr val="tx1"/>
+                </a:solidFill>
+                <a:effectLst/>
+                <a:latin typeface="Arial" panose="020B0604020202020204" pitchFamily="34" charset="0"/>
+              </a:rPr>
+              <a:t>.</a:t>
+            </a:r>
+          </a:p>
+        </p:txBody>
+      </p:sp>
+    </p:spTree>
+    <p:extLst>
+      <p:ext uri="{BB962C8B-B14F-4D97-AF65-F5344CB8AC3E}">
+        <p14:creationId xmlns:p14="http://schemas.microsoft.com/office/powerpoint/2010/main" val="1811723824"/>
+      </p:ext>
+    </p:extLst>
+  </p:cSld>
+  <p:clrMapOvr>
+    <a:masterClrMapping/>
+  </p:clrMapOvr>
+</p:sld>
+</file>
+
+<file path=ppt/slides/slide8.xml><?xml version="1.0" encoding="utf-8"?>
+<p:sld xmlns:a="http://schemas.openxmlformats.org/drawingml/2006/main" xmlns:r="http://schemas.openxmlformats.org/officeDocument/2006/relationships" xmlns:p="http://schemas.openxmlformats.org/presentationml/2006/main">
+  <p:cSld>
+    <p:spTree>
+      <p:nvGrpSpPr>
+        <p:cNvPr id="1" name="">
+          <a:extLst>
+            <a:ext uri="{FF2B5EF4-FFF2-40B4-BE49-F238E27FC236}">
+              <a16:creationId xmlns:a16="http://schemas.microsoft.com/office/drawing/2014/main" id="{619DAF4A-5D77-665C-D8CD-55B84D4F05B8}"/>
+            </a:ext>
+          </a:extLst>
+        </p:cNvPr>
+        <p:cNvGrpSpPr/>
+        <p:nvPr/>
+      </p:nvGrpSpPr>
+      <p:grpSpPr>
+        <a:xfrm>
+          <a:off x="0" y="0"/>
+          <a:ext cx="0" cy="0"/>
+          <a:chOff x="0" y="0"/>
+          <a:chExt cx="0" cy="0"/>
+        </a:xfrm>
+      </p:grpSpPr>
+      <p:sp>
+        <p:nvSpPr>
+          <p:cNvPr id="3" name="TextBox 2">
+            <a:extLst>
+              <a:ext uri="{FF2B5EF4-FFF2-40B4-BE49-F238E27FC236}">
+                <a16:creationId xmlns:a16="http://schemas.microsoft.com/office/drawing/2014/main" id="{643D6726-5F1E-A7B9-C16A-7EA22CEFA96B}"/>
+              </a:ext>
+            </a:extLst>
+          </p:cNvPr>
+          <p:cNvSpPr txBox="1"/>
+          <p:nvPr/>
+        </p:nvSpPr>
+        <p:spPr>
+          <a:xfrm>
+            <a:off x="217714" y="255046"/>
+            <a:ext cx="11756571" cy="355354"/>
+          </a:xfrm>
+          <a:prstGeom prst="rect">
+            <a:avLst/>
+          </a:prstGeom>
+          <a:noFill/>
+        </p:spPr>
+        <p:txBody>
+          <a:bodyPr wrap="square">
+            <a:spAutoFit/>
+          </a:bodyPr>
+          <a:lstStyle/>
+          <a:p>
+            <a:pPr>
+              <a:lnSpc>
+                <a:spcPct val="150000"/>
+              </a:lnSpc>
+              <a:buNone/>
+            </a:pPr>
+            <a:r>
+              <a:rPr kumimoji="0" lang="en-US" altLang="en-US" sz="1300" b="0" i="0" u="none" strike="noStrike" cap="none" normalizeH="0" baseline="0">
+                <a:ln>
+                  <a:noFill/>
+                </a:ln>
+                <a:solidFill>
+                  <a:schemeClr val="tx1"/>
+                </a:solidFill>
+                <a:effectLst/>
+                <a:latin typeface="Arial" panose="020B0604020202020204" pitchFamily="34" charset="0"/>
+              </a:rPr>
+              <a:t>.</a:t>
+            </a:r>
+          </a:p>
+        </p:txBody>
+      </p:sp>
+    </p:spTree>
+    <p:extLst>
+      <p:ext uri="{BB962C8B-B14F-4D97-AF65-F5344CB8AC3E}">
+        <p14:creationId xmlns:p14="http://schemas.microsoft.com/office/powerpoint/2010/main" val="1779772482"/>
+      </p:ext>
+    </p:extLst>
+  </p:cSld>
+  <p:clrMapOvr>
+    <a:masterClrMapping/>
+  </p:clrMapOvr>
+</p:sld>
+</file>
+
+<file path=ppt/slides/slide9.xml><?xml version="1.0" encoding="utf-8"?>
 <p:sld xmlns:a="http://schemas.openxmlformats.org/drawingml/2006/main" xmlns:r="http://schemas.openxmlformats.org/officeDocument/2006/relationships" xmlns:p="http://schemas.openxmlformats.org/presentationml/2006/main">
   <p:cSld>
     <p:spTree>

</xml_diff>